<commit_message>
docs: deck reflects the instant WhatsApp reply flow
Co-Authored-By: Claude Opus 5 (1M context) <noreply@anthropic.com>
</commit_message>
<xml_diff>
--- a/docs/Leda-Hackathon-Demo.pptx
+++ b/docs/Leda-Hackathon-Demo.pptx
@@ -2574,7 +2574,7 @@
                 <a:ea typeface="Calibri" pitchFamily="34" charset="-122"/>
                 <a:cs typeface="Calibri" pitchFamily="34" charset="-120"/>
               </a:rPr>
-              <a:t>Retailer sends a voice note</a:t>
+              <a:t>Retailer asks, then orders</a:t>
             </a:r>
             <a:endParaRPr lang="en-US" sz="1400" dirty="0"/>
           </a:p>
@@ -2613,7 +2613,7 @@
                 <a:ea typeface="Calibri" pitchFamily="34" charset="-122"/>
                 <a:cs typeface="Calibri" pitchFamily="34" charset="-120"/>
               </a:rPr>
-              <a:t>“Send me like fifty, make e remain small…” arrives on WhatsApp.</a:t>
+              <a:t>“Do you have onion?” gets prices back instantly. Then a voice note: “like fifty, make e remain small…”</a:t>
             </a:r>
             <a:endParaRPr lang="en-US" sz="1150" dirty="0"/>
           </a:p>
@@ -2739,7 +2739,7 @@
                 <a:ea typeface="Calibri" pitchFamily="34" charset="-122"/>
                 <a:cs typeface="Calibri" pitchFamily="34" charset="-120"/>
               </a:rPr>
-              <a:t>Command Center</a:t>
+              <a:t>Sabi asks back</a:t>
             </a:r>
             <a:endParaRPr lang="en-US" sz="1400" dirty="0"/>
           </a:p>
@@ -2778,7 +2778,7 @@
                 <a:ea typeface="Calibri" pitchFamily="34" charset="-122"/>
                 <a:cs typeface="Calibri" pitchFamily="34" charset="-120"/>
               </a:rPr>
-              <a:t>LE-1043 appears with two flags and Sabi's reasoning.</a:t>
+              <a:t>The retailer receives “1) 50 bags  2) 55 bags”, replies ‘2’, and gets the invoice and account number.</a:t>
             </a:r>
             <a:endParaRPr lang="en-US" sz="1150" dirty="0"/>
           </a:p>
@@ -2904,7 +2904,7 @@
                 <a:ea typeface="Calibri" pitchFamily="34" charset="-122"/>
                 <a:cs typeface="Calibri" pitchFamily="34" charset="-120"/>
               </a:rPr>
-              <a:t>War Room</a:t>
+              <a:t>Command Center</a:t>
             </a:r>
             <a:endParaRPr lang="en-US" sz="1400" dirty="0"/>
           </a:p>
@@ -2943,7 +2943,7 @@
                 <a:ea typeface="Calibri" pitchFamily="34" charset="-122"/>
                 <a:cs typeface="Calibri" pitchFamily="34" charset="-120"/>
               </a:rPr>
-              <a:t>Compare to the evidence, pick 55 bags, send the confirmation.</a:t>
+              <a:t>LE-1043 is already invoiced; the distributor sees the evidence and the reply in the War Room.</a:t>
             </a:r>
             <a:endParaRPr lang="en-US" sz="1150" dirty="0"/>
           </a:p>
@@ -5192,7 +5192,7 @@
                 <a:ea typeface="Calibri" pitchFamily="34" charset="-122"/>
                 <a:cs typeface="Calibri" pitchFamily="34" charset="-120"/>
               </a:rPr>
-              <a:t>Anything uncertain is a flag with Sabi's reasoning and two concrete options. One click resolves it; one click asks the retailer.</a:t>
+              <a:t>Anything uncertain becomes a question with two concrete options, sent straight back to the retailer. They reply "2"; Sabi finalises.</a:t>
             </a:r>
             <a:endParaRPr lang="en-US" sz="1150" dirty="0"/>
           </a:p>
@@ -5356,7 +5356,7 @@
                 <a:ea typeface="Calibri" pitchFamily="34" charset="-122"/>
                 <a:cs typeface="Calibri" pitchFamily="34" charset="-120"/>
               </a:rPr>
-              <a:t>Every retailer gets a virtual account. Transfers auto-match to invoices and post to an append-only ledger.</a:t>
+              <a:t>The reply carries the invoice and the retailer's own virtual account. Transfers auto-match and post to an append-only ledger.</a:t>
             </a:r>
             <a:endParaRPr lang="en-US" sz="1150" dirty="0"/>
           </a:p>
@@ -6779,7 +6779,7 @@
                 <a:ea typeface="Calibri" pitchFamily="34" charset="-122"/>
                 <a:cs typeface="Calibri" pitchFamily="34" charset="-120"/>
               </a:rPr>
-              <a:t>Order</a:t>
+              <a:t>Reply</a:t>
             </a:r>
             <a:endParaRPr lang="en-US" sz="1400" dirty="0"/>
           </a:p>
@@ -6821,7 +6821,7 @@
                 <a:ea typeface="Calibri" pitchFamily="34" charset="-122"/>
                 <a:cs typeface="Calibri" pitchFamily="34" charset="-120"/>
               </a:rPr>
-              <a:t>Lines with confidence.</a:t>
+              <a:t>Prices, invoice and account</a:t>
             </a:r>
             <a:endParaRPr lang="en-US" sz="950" dirty="0"/>
           </a:p>
@@ -6841,7 +6841,27 @@
                 <a:ea typeface="Calibri" pitchFamily="34" charset="-122"/>
                 <a:cs typeface="Calibri" pitchFamily="34" charset="-120"/>
               </a:rPr>
-              <a:t>Under 85 = human check.</a:t>
+              <a:t>number back on WhatsApp</a:t>
+            </a:r>
+            <a:endParaRPr lang="en-US" sz="950" dirty="0"/>
+          </a:p>
+          <a:p>
+            <a:pPr indent="0" marL="0">
+              <a:lnSpc>
+                <a:spcPct val="112000"/>
+              </a:lnSpc>
+              <a:buNone/>
+            </a:pPr>
+            <a:r>
+              <a:rPr lang="en-US" sz="950" dirty="0">
+                <a:solidFill>
+                  <a:srgbClr val="5B6B63"/>
+                </a:solidFill>
+                <a:latin typeface="Calibri" pitchFamily="34" charset="0"/>
+                <a:ea typeface="Calibri" pitchFamily="34" charset="-122"/>
+                <a:cs typeface="Calibri" pitchFamily="34" charset="-120"/>
+              </a:rPr>
+              <a:t>in seconds.</a:t>
             </a:r>
             <a:endParaRPr lang="en-US" sz="950" dirty="0"/>
           </a:p>
@@ -7044,7 +7064,7 @@
                 <a:ea typeface="Calibri" pitchFamily="34" charset="-122"/>
                 <a:cs typeface="Calibri" pitchFamily="34" charset="-120"/>
               </a:rPr>
-              <a:t>“Like fifty” with “make e remain small” could mean 50 or 55 bags of Royal Stallion 50kg. Sabi offers both and states the money at stake instead of guessing.</a:t>
+              <a:t>Sabi replies: “1) 50 bags  2) 55 bags — reply with the number.” The retailer answers ‘2’ and the invoice with their account number follows immediately. No guessing with the distributor's money.</a:t>
             </a:r>
             <a:endParaRPr lang="en-US" sz="1050" dirty="0"/>
           </a:p>

</xml_diff>